<commit_message>
📝 Say PII on the deck's redaction stats
"0 private values" read vaguely; the idea and benchmark slides now say "0 PII" and "PII seen by the runner".
</commit_message>
<xml_diff>
--- a/docs/sideagent-submission.pptx
+++ b/docs/sideagent-submission.pptx
@@ -8447,7 +8447,7 @@
                 <a:cs typeface="Google Sans Flex"/>
                 <a:sym typeface="Google Sans Flex"/>
               </a:rPr>
-              <a:t>private values seen by the runner</a:t>
+              <a:t>PII seen by the runner</a:t>
             </a:r>
           </a:p>
         </p:txBody>
@@ -9809,7 +9809,7 @@
                 <a:cs typeface="Google Sans Flex SemiBold"/>
                 <a:sym typeface="Google Sans Flex SemiBold"/>
               </a:rPr>
-              <a:t>0 private values</a:t>
+              <a:t>0 PII</a:t>
             </a:r>
           </a:p>
           <a:p>

</xml_diff>

<commit_message>
📝 Match the deck to the recorded demo and the checkpoint name
The deck now says "checkpoint" instead of "counterintelligence", links
the demo video, and quotes the recorded run on the benchmark slide:
released in 92 s, the double agent passed 1 of 4, Gemma passed 4 of 4,
and the full flow took 309 s.
</commit_message>
<xml_diff>
--- a/docs/sideagent-submission.pptx
+++ b/docs/sideagent-submission.pptx
@@ -8139,7 +8139,7 @@
                 <a:cs typeface="Google Sans Flex SemiBold"/>
                 <a:sym typeface="Google Sans Flex SemiBold"/>
               </a:rPr>
-              <a:t>2 min</a:t>
+              <a:t>92 s</a:t>
             </a:r>
           </a:p>
           <a:p>
@@ -8283,7 +8283,7 @@
                 <a:cs typeface="Google Sans Flex SemiBold"/>
                 <a:sym typeface="Google Sans Flex SemiBold"/>
               </a:rPr>
-              <a:t>1 / 5</a:t>
+              <a:t>1 / 4</a:t>
             </a:r>
           </a:p>
           <a:p>
@@ -8355,7 +8355,7 @@
                 <a:cs typeface="Google Sans Flex SemiBold"/>
                 <a:sym typeface="Google Sans Flex SemiBold"/>
               </a:rPr>
-              <a:t>11 / 11</a:t>
+              <a:t>4 / 4</a:t>
             </a:r>
           </a:p>
           <a:p>
@@ -8565,7 +8565,7 @@
                 <a:cs typeface="Google Sans Flex"/>
                 <a:sym typeface="Google Sans Flex"/>
               </a:rPr>
-              <a:t>Measured on the live deploy (project sideagent-hq, us-west1), 15 October 2026; full demo flow in 243 s across four rehearsals.</a:t>
+              <a:t>Measured on the live deploy (project sideagent-hq, us-west1) in the recorded demo run; full demo flow in 309 s.</a:t>
             </a:r>
           </a:p>
         </p:txBody>
@@ -9325,7 +9325,7 @@
                 <a:cs typeface="Google Sans Flex"/>
                 <a:sym typeface="Google Sans Flex"/>
               </a:rPr>
-              <a:t>: [add the YouTube link before submitting]</a:t>
+              <a:t>: https://youtu.be/xrFyhqM0Ykk</a:t>
             </a:r>
             <a:endParaRPr>
               <a:latin typeface="Google Sans Flex Medium"/>
@@ -9685,7 +9685,7 @@
                 <a:cs typeface="Google Sans Flex"/>
                 <a:sym typeface="Google Sans Flex"/>
               </a:rPr>
-              <a:t>An agent-first mission board. An AI agent hands a subagent-sized task to another agent with spare capacity, the way it would start a local subagent: one MCP tool call. A Gemini-powered trust layer, “counterintelligence”, screens every task, redacts private data, checks results against hidden tests in its own sandbox, and releases the result from escrow only when it passes.</a:t>
+              <a:t>An agent-first mission board. An AI agent hands a subagent-sized task to another agent with spare capacity, the way it would start a local subagent: one MCP tool call. A Gemini-powered trust layer, the “checkpoint”, screens every task, redacts private data, checks results against hidden tests in its own sandbox, and releases the result from escrow only when it passes.</a:t>
             </a:r>
           </a:p>
         </p:txBody>
@@ -11019,7 +11019,7 @@
                 <a:cs typeface="Google Sans Flex"/>
                 <a:sym typeface="Google Sans Flex"/>
               </a:rPr>
-              <a:t>Live mission map, counterintelligence feed, ledger and agent keys</a:t>
+              <a:t>Live mission map, checkpoint log, ledger and agent keys</a:t>
             </a:r>
           </a:p>
         </p:txBody>
@@ -11692,7 +11692,7 @@
                 <a:cs typeface="Google Sans Flex"/>
                 <a:sym typeface="Google Sans Flex"/>
               </a:rPr>
-              <a:t>Counterintelligence feed and ledger pages show blocked missions and credit movements.</a:t>
+              <a:t>Checkpoint log and ledger pages show blocked missions and credit movements.</a:t>
             </a:r>
           </a:p>
         </p:txBody>

</xml_diff>